<commit_message>
Hero visual complete and build stabilized
</commit_message>
<xml_diff>
--- a/public/downloads/capability-statement.pptx
+++ b/public/downloads/capability-statement.pptx
@@ -5213,7 +5213,7 @@
                 <a:ea typeface="Arial" pitchFamily="34" charset="-122"/>
                 <a:cs typeface="Arial" pitchFamily="34" charset="-120"/>
               </a:rPr>
-              <a:t>Website: https://inframind-ai-website.vercel.app
+              <a:t>Website: https://inframindepc.com
 </a:t>
             </a:r>
             <a:pPr indent="0" marL="0">
@@ -5228,7 +5228,7 @@
                 <a:ea typeface="Arial" pitchFamily="34" charset="-122"/>
                 <a:cs typeface="Arial" pitchFamily="34" charset="-120"/>
               </a:rPr>
-              <a:t>Contact Page: https://inframind-ai-website.vercel.app/contact
+              <a:t>Contact: https://inframindepc.com/contact
 </a:t>
             </a:r>
             <a:endParaRPr lang="en-US" sz="1800" dirty="0"/>

</xml_diff>

<commit_message>
Release Public Knowledge Library v1.0
</commit_message>
<xml_diff>
--- a/public/downloads/capability-statement.pptx
+++ b/public/downloads/capability-statement.pptx
@@ -1349,9 +1349,9 @@
                 <a:solidFill>
                   <a:srgbClr val="D1D5DB"/>
                 </a:solidFill>
-                <a:latin typeface="Arial" pitchFamily="34" charset="0"/>
-                <a:ea typeface="Arial" pitchFamily="34" charset="-122"/>
-                <a:cs typeface="Arial" pitchFamily="34" charset="-120"/>
+                <a:latin typeface="Inter" pitchFamily="34" charset="0"/>
+                <a:ea typeface="Inter" pitchFamily="34" charset="-122"/>
+                <a:cs typeface="Inter" pitchFamily="34" charset="-120"/>
               </a:rPr>
               <a:t>InfraMind AI</a:t>
             </a:r>
@@ -1388,9 +1388,9 @@
                 <a:solidFill>
                   <a:srgbClr val="9CA3AF"/>
                 </a:solidFill>
-                <a:latin typeface="Arial" pitchFamily="34" charset="0"/>
-                <a:ea typeface="Arial" pitchFamily="34" charset="-122"/>
-                <a:cs typeface="Arial" pitchFamily="34" charset="-120"/>
+                <a:latin typeface="Inter" pitchFamily="34" charset="0"/>
+                <a:ea typeface="Inter" pitchFamily="34" charset="-122"/>
+                <a:cs typeface="Inter" pitchFamily="34" charset="-120"/>
               </a:rPr>
               <a:t>Executive Capability Statement</a:t>
             </a:r>
@@ -1427,9 +1427,9 @@
                 <a:solidFill>
                   <a:srgbClr val="2A6094"/>
                 </a:solidFill>
-                <a:latin typeface="Arial" pitchFamily="34" charset="0"/>
-                <a:ea typeface="Arial" pitchFamily="34" charset="-122"/>
-                <a:cs typeface="Arial" pitchFamily="34" charset="-120"/>
+                <a:latin typeface="Inter" pitchFamily="34" charset="0"/>
+                <a:ea typeface="Inter" pitchFamily="34" charset="-122"/>
+                <a:cs typeface="Inter" pitchFamily="34" charset="-120"/>
               </a:rPr>
               <a:t>AI-Enabled EPC Operational Intelligence</a:t>
             </a:r>
@@ -1466,9 +1466,9 @@
                 <a:solidFill>
                   <a:srgbClr val="9CA3AF"/>
                 </a:solidFill>
-                <a:latin typeface="Arial" pitchFamily="34" charset="0"/>
-                <a:ea typeface="Arial" pitchFamily="34" charset="-122"/>
-                <a:cs typeface="Arial" pitchFamily="34" charset="-120"/>
+                <a:latin typeface="Inter" pitchFamily="34" charset="0"/>
+                <a:ea typeface="Inter" pitchFamily="34" charset="-122"/>
+                <a:cs typeface="Inter" pitchFamily="34" charset="-120"/>
               </a:rPr>
               <a:t>June 2026</a:t>
             </a:r>
@@ -1537,9 +1537,9 @@
                 <a:solidFill>
                   <a:srgbClr val="D1D5DB"/>
                 </a:solidFill>
-                <a:latin typeface="Arial" pitchFamily="34" charset="0"/>
-                <a:ea typeface="Arial" pitchFamily="34" charset="-122"/>
-                <a:cs typeface="Arial" pitchFamily="34" charset="-120"/>
+                <a:latin typeface="Inter" pitchFamily="34" charset="0"/>
+                <a:ea typeface="Inter" pitchFamily="34" charset="-122"/>
+                <a:cs typeface="Inter" pitchFamily="34" charset="-120"/>
               </a:rPr>
               <a:t>Executive Summary</a:t>
             </a:r>
@@ -1576,9 +1576,9 @@
                 <a:solidFill>
                   <a:srgbClr val="2A6094"/>
                 </a:solidFill>
-                <a:latin typeface="Arial" pitchFamily="34" charset="0"/>
-                <a:ea typeface="Arial" pitchFamily="34" charset="-122"/>
-                <a:cs typeface="Arial" pitchFamily="34" charset="-120"/>
+                <a:latin typeface="Inter" pitchFamily="34" charset="0"/>
+                <a:ea typeface="Inter" pitchFamily="34" charset="-122"/>
+                <a:cs typeface="Inter" pitchFamily="34" charset="-120"/>
               </a:rPr>
               <a:t>InfraMind AI </a:t>
             </a:r>
@@ -1590,9 +1590,9 @@
                 <a:solidFill>
                   <a:srgbClr val="D1D5DB"/>
                 </a:solidFill>
-                <a:latin typeface="Arial" pitchFamily="34" charset="0"/>
-                <a:ea typeface="Arial" pitchFamily="34" charset="-122"/>
-                <a:cs typeface="Arial" pitchFamily="34" charset="-120"/>
+                <a:latin typeface="Inter" pitchFamily="34" charset="0"/>
+                <a:ea typeface="Inter" pitchFamily="34" charset="-122"/>
+                <a:cs typeface="Inter" pitchFamily="34" charset="-120"/>
               </a:rPr>
               <a:t>delivers practitioner-built AI operational intelligence systems for EPC megaprojects. Founded by </a:t>
             </a:r>
@@ -1604,9 +1604,9 @@
                 <a:solidFill>
                   <a:srgbClr val="D1D5DB"/>
                 </a:solidFill>
-                <a:latin typeface="Arial" pitchFamily="34" charset="0"/>
-                <a:ea typeface="Arial" pitchFamily="34" charset="-122"/>
-                <a:cs typeface="Arial" pitchFamily="34" charset="-120"/>
+                <a:latin typeface="Inter" pitchFamily="34" charset="0"/>
+                <a:ea typeface="Inter" pitchFamily="34" charset="-122"/>
+                <a:cs typeface="Inter" pitchFamily="34" charset="-120"/>
               </a:rPr>
               <a:t>Samanta Nayak</a:t>
             </a:r>
@@ -1618,9 +1618,9 @@
                 <a:solidFill>
                   <a:srgbClr val="D1D5DB"/>
                 </a:solidFill>
-                <a:latin typeface="Arial" pitchFamily="34" charset="0"/>
-                <a:ea typeface="Arial" pitchFamily="34" charset="-122"/>
-                <a:cs typeface="Arial" pitchFamily="34" charset="-120"/>
+                <a:latin typeface="Inter" pitchFamily="34" charset="0"/>
+                <a:ea typeface="Inter" pitchFamily="34" charset="-122"/>
+                <a:cs typeface="Inter" pitchFamily="34" charset="-120"/>
               </a:rPr>
               <a:t> — a 20+ year EPC infrastructure veteran and ICC Arbitration Fact Witness — InfraMind AI encodes real-world contract administration expertise into deployed AI-augmented systems.</a:t>
             </a:r>
@@ -1657,9 +1657,9 @@
                 <a:solidFill>
                   <a:srgbClr val="9CA3AF"/>
                 </a:solidFill>
-                <a:latin typeface="Arial" pitchFamily="34" charset="0"/>
-                <a:ea typeface="Arial" pitchFamily="34" charset="-122"/>
-                <a:cs typeface="Arial" pitchFamily="34" charset="-120"/>
+                <a:latin typeface="Inter" pitchFamily="34" charset="0"/>
+                <a:ea typeface="Inter" pitchFamily="34" charset="-122"/>
+                <a:cs typeface="Inter" pitchFamily="34" charset="-120"/>
               </a:rPr>
               <a:t>Mission: Eliminate the information lag that transforms manageable risks into costly disputes on infrastructure megaprojects.</a:t>
             </a:r>
@@ -1696,9 +1696,9 @@
                 <a:solidFill>
                   <a:srgbClr val="2A6094"/>
                 </a:solidFill>
-                <a:latin typeface="Arial" pitchFamily="34" charset="0"/>
-                <a:ea typeface="Arial" pitchFamily="34" charset="-122"/>
-                <a:cs typeface="Arial" pitchFamily="34" charset="-120"/>
+                <a:latin typeface="Inter" pitchFamily="34" charset="0"/>
+                <a:ea typeface="Inter" pitchFamily="34" charset="-122"/>
+                <a:cs typeface="Inter" pitchFamily="34" charset="-120"/>
               </a:rPr>
               <a:t>The Rarest Combination</a:t>
             </a:r>
@@ -1746,16 +1746,16 @@
                           <a:solidFill>
                             <a:srgbClr val="FFFFFF"/>
                           </a:solidFill>
-                          <a:latin typeface="Arial" pitchFamily="34" charset="0"/>
-                          <a:ea typeface="Arial" pitchFamily="34" charset="-122"/>
-                          <a:cs typeface="Arial" pitchFamily="34" charset="-120"/>
+                          <a:latin typeface="Inter" pitchFamily="34" charset="0"/>
+                          <a:ea typeface="Inter" pitchFamily="34" charset="-122"/>
+                          <a:cs typeface="Inter" pitchFamily="34" charset="-120"/>
                         </a:rPr>
                         <a:t>Dimension</a:t>
                       </a:r>
                       <a:endParaRPr lang="en-US" sz="1100" dirty="0">
-                        <a:latin typeface="Arial" charset="0"/>
-                        <a:ea typeface="Arial" charset="0"/>
-                        <a:cs typeface="Arial" charset="0"/>
+                        <a:latin typeface="Inter" charset="0"/>
+                        <a:ea typeface="Inter" charset="0"/>
+                        <a:cs typeface="Inter" charset="0"/>
                       </a:endParaRPr>
                     </a:p>
                   </a:txBody>
@@ -1790,16 +1790,16 @@
                           <a:solidFill>
                             <a:srgbClr val="FFFFFF"/>
                           </a:solidFill>
-                          <a:latin typeface="Arial" pitchFamily="34" charset="0"/>
-                          <a:ea typeface="Arial" pitchFamily="34" charset="-122"/>
-                          <a:cs typeface="Arial" pitchFamily="34" charset="-120"/>
+                          <a:latin typeface="Inter" pitchFamily="34" charset="0"/>
+                          <a:ea typeface="Inter" pitchFamily="34" charset="-122"/>
+                          <a:cs typeface="Inter" pitchFamily="34" charset="-120"/>
                         </a:rPr>
                         <a:t>Capability</a:t>
                       </a:r>
                       <a:endParaRPr lang="en-US" sz="1100" dirty="0">
-                        <a:latin typeface="Arial" charset="0"/>
-                        <a:ea typeface="Arial" charset="0"/>
-                        <a:cs typeface="Arial" charset="0"/>
+                        <a:latin typeface="Inter" charset="0"/>
+                        <a:ea typeface="Inter" charset="0"/>
+                        <a:cs typeface="Inter" charset="0"/>
                       </a:endParaRPr>
                     </a:p>
                   </a:txBody>
@@ -1836,16 +1836,16 @@
                           <a:solidFill>
                             <a:srgbClr val="D1D5DB"/>
                           </a:solidFill>
-                          <a:latin typeface="Arial" pitchFamily="34" charset="0"/>
-                          <a:ea typeface="Arial" pitchFamily="34" charset="-122"/>
-                          <a:cs typeface="Arial" pitchFamily="34" charset="-120"/>
+                          <a:latin typeface="Inter" pitchFamily="34" charset="0"/>
+                          <a:ea typeface="Inter" pitchFamily="34" charset="-122"/>
+                          <a:cs typeface="Inter" pitchFamily="34" charset="-120"/>
                         </a:rPr>
                         <a:t>Experience</a:t>
                       </a:r>
                       <a:endParaRPr lang="en-US" sz="1000" dirty="0">
-                        <a:latin typeface="Arial" charset="0"/>
-                        <a:ea typeface="Arial" charset="0"/>
-                        <a:cs typeface="Arial" charset="0"/>
+                        <a:latin typeface="Inter" charset="0"/>
+                        <a:ea typeface="Inter" charset="0"/>
+                        <a:cs typeface="Inter" charset="0"/>
                       </a:endParaRPr>
                     </a:p>
                   </a:txBody>
@@ -1880,16 +1880,16 @@
                           <a:solidFill>
                             <a:srgbClr val="D1D5DB"/>
                           </a:solidFill>
-                          <a:latin typeface="Arial" pitchFamily="34" charset="0"/>
-                          <a:ea typeface="Arial" pitchFamily="34" charset="-122"/>
-                          <a:cs typeface="Arial" pitchFamily="34" charset="-120"/>
+                          <a:latin typeface="Inter" pitchFamily="34" charset="0"/>
+                          <a:ea typeface="Inter" pitchFamily="34" charset="-122"/>
+                          <a:cs typeface="Inter" pitchFamily="34" charset="-120"/>
                         </a:rPr>
                         <a:t>20+ years EPC infrastructure</a:t>
                       </a:r>
                       <a:endParaRPr lang="en-US" sz="1000" dirty="0">
-                        <a:latin typeface="Arial" charset="0"/>
-                        <a:ea typeface="Arial" charset="0"/>
-                        <a:cs typeface="Arial" charset="0"/>
+                        <a:latin typeface="Inter" charset="0"/>
+                        <a:ea typeface="Inter" charset="0"/>
+                        <a:cs typeface="Inter" charset="0"/>
                       </a:endParaRPr>
                     </a:p>
                   </a:txBody>
@@ -1926,16 +1926,16 @@
                           <a:solidFill>
                             <a:srgbClr val="D1D5DB"/>
                           </a:solidFill>
-                          <a:latin typeface="Arial" pitchFamily="34" charset="0"/>
-                          <a:ea typeface="Arial" pitchFamily="34" charset="-122"/>
-                          <a:cs typeface="Arial" pitchFamily="34" charset="-120"/>
+                          <a:latin typeface="Inter" pitchFamily="34" charset="0"/>
+                          <a:ea typeface="Inter" pitchFamily="34" charset="-122"/>
+                          <a:cs typeface="Inter" pitchFamily="34" charset="-120"/>
                         </a:rPr>
                         <a:t>Domain</a:t>
                       </a:r>
                       <a:endParaRPr lang="en-US" sz="1000" dirty="0">
-                        <a:latin typeface="Arial" charset="0"/>
-                        <a:ea typeface="Arial" charset="0"/>
-                        <a:cs typeface="Arial" charset="0"/>
+                        <a:latin typeface="Inter" charset="0"/>
+                        <a:ea typeface="Inter" charset="0"/>
+                        <a:cs typeface="Inter" charset="0"/>
                       </a:endParaRPr>
                     </a:p>
                   </a:txBody>
@@ -1970,16 +1970,16 @@
                           <a:solidFill>
                             <a:srgbClr val="D1D5DB"/>
                           </a:solidFill>
-                          <a:latin typeface="Arial" pitchFamily="34" charset="0"/>
-                          <a:ea typeface="Arial" pitchFamily="34" charset="-122"/>
-                          <a:cs typeface="Arial" pitchFamily="34" charset="-120"/>
+                          <a:latin typeface="Inter" pitchFamily="34" charset="0"/>
+                          <a:ea typeface="Inter" pitchFamily="34" charset="-122"/>
+                          <a:cs typeface="Inter" pitchFamily="34" charset="-120"/>
                         </a:rPr>
                         <a:t>FIDIC contract administration, claims &amp; dispute resolution</a:t>
                       </a:r>
                       <a:endParaRPr lang="en-US" sz="1000" dirty="0">
-                        <a:latin typeface="Arial" charset="0"/>
-                        <a:ea typeface="Arial" charset="0"/>
-                        <a:cs typeface="Arial" charset="0"/>
+                        <a:latin typeface="Inter" charset="0"/>
+                        <a:ea typeface="Inter" charset="0"/>
+                        <a:cs typeface="Inter" charset="0"/>
                       </a:endParaRPr>
                     </a:p>
                   </a:txBody>
@@ -2016,16 +2016,16 @@
                           <a:solidFill>
                             <a:srgbClr val="D1D5DB"/>
                           </a:solidFill>
-                          <a:latin typeface="Arial" pitchFamily="34" charset="0"/>
-                          <a:ea typeface="Arial" pitchFamily="34" charset="-122"/>
-                          <a:cs typeface="Arial" pitchFamily="34" charset="-120"/>
+                          <a:latin typeface="Inter" pitchFamily="34" charset="0"/>
+                          <a:ea typeface="Inter" pitchFamily="34" charset="-122"/>
+                          <a:cs typeface="Inter" pitchFamily="34" charset="-120"/>
                         </a:rPr>
                         <a:t>Technical</a:t>
                       </a:r>
                       <a:endParaRPr lang="en-US" sz="1000" dirty="0">
-                        <a:latin typeface="Arial" charset="0"/>
-                        <a:ea typeface="Arial" charset="0"/>
-                        <a:cs typeface="Arial" charset="0"/>
+                        <a:latin typeface="Inter" charset="0"/>
+                        <a:ea typeface="Inter" charset="0"/>
+                        <a:cs typeface="Inter" charset="0"/>
                       </a:endParaRPr>
                     </a:p>
                   </a:txBody>
@@ -2060,16 +2060,16 @@
                           <a:solidFill>
                             <a:srgbClr val="D1D5DB"/>
                           </a:solidFill>
-                          <a:latin typeface="Arial" pitchFamily="34" charset="0"/>
-                          <a:ea typeface="Arial" pitchFamily="34" charset="-122"/>
-                          <a:cs typeface="Arial" pitchFamily="34" charset="-120"/>
+                          <a:latin typeface="Inter" pitchFamily="34" charset="0"/>
+                          <a:ea typeface="Inter" pitchFamily="34" charset="-122"/>
+                          <a:cs typeface="Inter" pitchFamily="34" charset="-120"/>
                         </a:rPr>
                         <a:t>AI engineering, full-stack development</a:t>
                       </a:r>
                       <a:endParaRPr lang="en-US" sz="1000" dirty="0">
-                        <a:latin typeface="Arial" charset="0"/>
-                        <a:ea typeface="Arial" charset="0"/>
-                        <a:cs typeface="Arial" charset="0"/>
+                        <a:latin typeface="Inter" charset="0"/>
+                        <a:ea typeface="Inter" charset="0"/>
+                        <a:cs typeface="Inter" charset="0"/>
                       </a:endParaRPr>
                     </a:p>
                   </a:txBody>
@@ -2106,16 +2106,16 @@
                           <a:solidFill>
                             <a:srgbClr val="D1D5DB"/>
                           </a:solidFill>
-                          <a:latin typeface="Arial" pitchFamily="34" charset="0"/>
-                          <a:ea typeface="Arial" pitchFamily="34" charset="-122"/>
-                          <a:cs typeface="Arial" pitchFamily="34" charset="-120"/>
+                          <a:latin typeface="Inter" pitchFamily="34" charset="0"/>
+                          <a:ea typeface="Inter" pitchFamily="34" charset="-122"/>
+                          <a:cs typeface="Inter" pitchFamily="34" charset="-120"/>
                         </a:rPr>
                         <a:t>Credibility</a:t>
                       </a:r>
                       <a:endParaRPr lang="en-US" sz="1000" dirty="0">
-                        <a:latin typeface="Arial" charset="0"/>
-                        <a:ea typeface="Arial" charset="0"/>
-                        <a:cs typeface="Arial" charset="0"/>
+                        <a:latin typeface="Inter" charset="0"/>
+                        <a:ea typeface="Inter" charset="0"/>
+                        <a:cs typeface="Inter" charset="0"/>
                       </a:endParaRPr>
                     </a:p>
                   </a:txBody>
@@ -2150,16 +2150,16 @@
                           <a:solidFill>
                             <a:srgbClr val="D1D5DB"/>
                           </a:solidFill>
-                          <a:latin typeface="Arial" pitchFamily="34" charset="0"/>
-                          <a:ea typeface="Arial" pitchFamily="34" charset="-122"/>
-                          <a:cs typeface="Arial" pitchFamily="34" charset="-120"/>
+                          <a:latin typeface="Inter" pitchFamily="34" charset="0"/>
+                          <a:ea typeface="Inter" pitchFamily="34" charset="-122"/>
+                          <a:cs typeface="Inter" pitchFamily="34" charset="-120"/>
                         </a:rPr>
                         <a:t>ICC Arbitration Fact Witness</a:t>
                       </a:r>
                       <a:endParaRPr lang="en-US" sz="1000" dirty="0">
-                        <a:latin typeface="Arial" charset="0"/>
-                        <a:ea typeface="Arial" charset="0"/>
-                        <a:cs typeface="Arial" charset="0"/>
+                        <a:latin typeface="Inter" charset="0"/>
+                        <a:ea typeface="Inter" charset="0"/>
+                        <a:cs typeface="Inter" charset="0"/>
                       </a:endParaRPr>
                     </a:p>
                   </a:txBody>
@@ -2196,16 +2196,16 @@
                           <a:solidFill>
                             <a:srgbClr val="D1D5DB"/>
                           </a:solidFill>
-                          <a:latin typeface="Arial" pitchFamily="34" charset="0"/>
-                          <a:ea typeface="Arial" pitchFamily="34" charset="-122"/>
-                          <a:cs typeface="Arial" pitchFamily="34" charset="-120"/>
+                          <a:latin typeface="Inter" pitchFamily="34" charset="0"/>
+                          <a:ea typeface="Inter" pitchFamily="34" charset="-122"/>
+                          <a:cs typeface="Inter" pitchFamily="34" charset="-120"/>
                         </a:rPr>
                         <a:t>Deployment</a:t>
                       </a:r>
                       <a:endParaRPr lang="en-US" sz="1000" dirty="0">
-                        <a:latin typeface="Arial" charset="0"/>
-                        <a:ea typeface="Arial" charset="0"/>
-                        <a:cs typeface="Arial" charset="0"/>
+                        <a:latin typeface="Inter" charset="0"/>
+                        <a:ea typeface="Inter" charset="0"/>
+                        <a:cs typeface="Inter" charset="0"/>
                       </a:endParaRPr>
                     </a:p>
                   </a:txBody>
@@ -2240,16 +2240,16 @@
                           <a:solidFill>
                             <a:srgbClr val="D1D5DB"/>
                           </a:solidFill>
-                          <a:latin typeface="Arial" pitchFamily="34" charset="0"/>
-                          <a:ea typeface="Arial" pitchFamily="34" charset="-122"/>
-                          <a:cs typeface="Arial" pitchFamily="34" charset="-120"/>
+                          <a:latin typeface="Inter" pitchFamily="34" charset="0"/>
+                          <a:ea typeface="Inter" pitchFamily="34" charset="-122"/>
+                          <a:cs typeface="Inter" pitchFamily="34" charset="-120"/>
                         </a:rPr>
                         <a:t>Live on MAHSR T-3 (INR 3,142 Crore FIDIC Yellow Book)</a:t>
                       </a:r>
                       <a:endParaRPr lang="en-US" sz="1000" dirty="0">
-                        <a:latin typeface="Arial" charset="0"/>
-                        <a:ea typeface="Arial" charset="0"/>
-                        <a:cs typeface="Arial" charset="0"/>
+                        <a:latin typeface="Inter" charset="0"/>
+                        <a:ea typeface="Inter" charset="0"/>
+                        <a:cs typeface="Inter" charset="0"/>
                       </a:endParaRPr>
                     </a:p>
                   </a:txBody>
@@ -2337,9 +2337,9 @@
                 <a:solidFill>
                   <a:srgbClr val="D1D5DB"/>
                 </a:solidFill>
-                <a:latin typeface="Arial" pitchFamily="34" charset="0"/>
-                <a:ea typeface="Arial" pitchFamily="34" charset="-122"/>
-                <a:cs typeface="Arial" pitchFamily="34" charset="-120"/>
+                <a:latin typeface="Inter" pitchFamily="34" charset="0"/>
+                <a:ea typeface="Inter" pitchFamily="34" charset="-122"/>
+                <a:cs typeface="Inter" pitchFamily="34" charset="-120"/>
               </a:rPr>
               <a:t>Operational Intelligence Products</a:t>
             </a:r>
@@ -2389,16 +2389,16 @@
                           <a:solidFill>
                             <a:srgbClr val="FFFFFF"/>
                           </a:solidFill>
-                          <a:latin typeface="Arial" pitchFamily="34" charset="0"/>
-                          <a:ea typeface="Arial" pitchFamily="34" charset="-122"/>
-                          <a:cs typeface="Arial" pitchFamily="34" charset="-120"/>
+                          <a:latin typeface="Inter" pitchFamily="34" charset="0"/>
+                          <a:ea typeface="Inter" pitchFamily="34" charset="-122"/>
+                          <a:cs typeface="Inter" pitchFamily="34" charset="-120"/>
                         </a:rPr>
                         <a:t>Product</a:t>
                       </a:r>
                       <a:endParaRPr lang="en-US" sz="1100" dirty="0">
-                        <a:latin typeface="Arial" charset="0"/>
-                        <a:ea typeface="Arial" charset="0"/>
-                        <a:cs typeface="Arial" charset="0"/>
+                        <a:latin typeface="Inter" charset="0"/>
+                        <a:ea typeface="Inter" charset="0"/>
+                        <a:cs typeface="Inter" charset="0"/>
                       </a:endParaRPr>
                     </a:p>
                   </a:txBody>
@@ -2433,16 +2433,16 @@
                           <a:solidFill>
                             <a:srgbClr val="FFFFFF"/>
                           </a:solidFill>
-                          <a:latin typeface="Arial" pitchFamily="34" charset="0"/>
-                          <a:ea typeface="Arial" pitchFamily="34" charset="-122"/>
-                          <a:cs typeface="Arial" pitchFamily="34" charset="-120"/>
+                          <a:latin typeface="Inter" pitchFamily="34" charset="0"/>
+                          <a:ea typeface="Inter" pitchFamily="34" charset="-122"/>
+                          <a:cs typeface="Inter" pitchFamily="34" charset="-120"/>
                         </a:rPr>
                         <a:t>Category</a:t>
                       </a:r>
                       <a:endParaRPr lang="en-US" sz="1100" dirty="0">
-                        <a:latin typeface="Arial" charset="0"/>
-                        <a:ea typeface="Arial" charset="0"/>
-                        <a:cs typeface="Arial" charset="0"/>
+                        <a:latin typeface="Inter" charset="0"/>
+                        <a:ea typeface="Inter" charset="0"/>
+                        <a:cs typeface="Inter" charset="0"/>
                       </a:endParaRPr>
                     </a:p>
                   </a:txBody>
@@ -2477,16 +2477,16 @@
                           <a:solidFill>
                             <a:srgbClr val="FFFFFF"/>
                           </a:solidFill>
-                          <a:latin typeface="Arial" pitchFamily="34" charset="0"/>
-                          <a:ea typeface="Arial" pitchFamily="34" charset="-122"/>
-                          <a:cs typeface="Arial" pitchFamily="34" charset="-120"/>
+                          <a:latin typeface="Inter" pitchFamily="34" charset="0"/>
+                          <a:ea typeface="Inter" pitchFamily="34" charset="-122"/>
+                          <a:cs typeface="Inter" pitchFamily="34" charset="-120"/>
                         </a:rPr>
                         <a:t>Status</a:t>
                       </a:r>
                       <a:endParaRPr lang="en-US" sz="1100" dirty="0">
-                        <a:latin typeface="Arial" charset="0"/>
-                        <a:ea typeface="Arial" charset="0"/>
-                        <a:cs typeface="Arial" charset="0"/>
+                        <a:latin typeface="Inter" charset="0"/>
+                        <a:ea typeface="Inter" charset="0"/>
+                        <a:cs typeface="Inter" charset="0"/>
                       </a:endParaRPr>
                     </a:p>
                   </a:txBody>
@@ -2521,16 +2521,16 @@
                           <a:solidFill>
                             <a:srgbClr val="FFFFFF"/>
                           </a:solidFill>
-                          <a:latin typeface="Arial" pitchFamily="34" charset="0"/>
-                          <a:ea typeface="Arial" pitchFamily="34" charset="-122"/>
-                          <a:cs typeface="Arial" pitchFamily="34" charset="-120"/>
+                          <a:latin typeface="Inter" pitchFamily="34" charset="0"/>
+                          <a:ea typeface="Inter" pitchFamily="34" charset="-122"/>
+                          <a:cs typeface="Inter" pitchFamily="34" charset="-120"/>
                         </a:rPr>
                         <a:t>Key Metric</a:t>
                       </a:r>
                       <a:endParaRPr lang="en-US" sz="1100" dirty="0">
-                        <a:latin typeface="Arial" charset="0"/>
-                        <a:ea typeface="Arial" charset="0"/>
-                        <a:cs typeface="Arial" charset="0"/>
+                        <a:latin typeface="Inter" charset="0"/>
+                        <a:ea typeface="Inter" charset="0"/>
+                        <a:cs typeface="Inter" charset="0"/>
                       </a:endParaRPr>
                     </a:p>
                   </a:txBody>
@@ -2567,16 +2567,16 @@
                           <a:solidFill>
                             <a:srgbClr val="D1D5DB"/>
                           </a:solidFill>
-                          <a:latin typeface="Arial" pitchFamily="34" charset="0"/>
-                          <a:ea typeface="Arial" pitchFamily="34" charset="-122"/>
-                          <a:cs typeface="Arial" pitchFamily="34" charset="-120"/>
+                          <a:latin typeface="Inter" pitchFamily="34" charset="0"/>
+                          <a:ea typeface="Inter" pitchFamily="34" charset="-122"/>
+                          <a:cs typeface="Inter" pitchFamily="34" charset="-120"/>
                         </a:rPr>
                         <a:t>MAHSR T-3 Digital Twin</a:t>
                       </a:r>
                       <a:endParaRPr lang="en-US" sz="1000" dirty="0">
-                        <a:latin typeface="Arial" charset="0"/>
-                        <a:ea typeface="Arial" charset="0"/>
-                        <a:cs typeface="Arial" charset="0"/>
+                        <a:latin typeface="Inter" charset="0"/>
+                        <a:ea typeface="Inter" charset="0"/>
+                        <a:cs typeface="Inter" charset="0"/>
                       </a:endParaRPr>
                     </a:p>
                   </a:txBody>
@@ -2611,16 +2611,16 @@
                           <a:solidFill>
                             <a:srgbClr val="D1D5DB"/>
                           </a:solidFill>
-                          <a:latin typeface="Arial" pitchFamily="34" charset="0"/>
-                          <a:ea typeface="Arial" pitchFamily="34" charset="-122"/>
-                          <a:cs typeface="Arial" pitchFamily="34" charset="-120"/>
+                          <a:latin typeface="Inter" pitchFamily="34" charset="0"/>
+                          <a:ea typeface="Inter" pitchFamily="34" charset="-122"/>
+                          <a:cs typeface="Inter" pitchFamily="34" charset="-120"/>
                         </a:rPr>
                         <a:t>Operational Intelligence</a:t>
                       </a:r>
                       <a:endParaRPr lang="en-US" sz="1000" dirty="0">
-                        <a:latin typeface="Arial" charset="0"/>
-                        <a:ea typeface="Arial" charset="0"/>
-                        <a:cs typeface="Arial" charset="0"/>
+                        <a:latin typeface="Inter" charset="0"/>
+                        <a:ea typeface="Inter" charset="0"/>
+                        <a:cs typeface="Inter" charset="0"/>
                       </a:endParaRPr>
                     </a:p>
                   </a:txBody>
@@ -2655,16 +2655,16 @@
                           <a:solidFill>
                             <a:srgbClr val="D1D5DB"/>
                           </a:solidFill>
-                          <a:latin typeface="Arial" pitchFamily="34" charset="0"/>
-                          <a:ea typeface="Arial" pitchFamily="34" charset="-122"/>
-                          <a:cs typeface="Arial" pitchFamily="34" charset="-120"/>
+                          <a:latin typeface="Inter" pitchFamily="34" charset="0"/>
+                          <a:ea typeface="Inter" pitchFamily="34" charset="-122"/>
+                          <a:cs typeface="Inter" pitchFamily="34" charset="-120"/>
                         </a:rPr>
                         <a:t>Production</a:t>
                       </a:r>
                       <a:endParaRPr lang="en-US" sz="1000" dirty="0">
-                        <a:latin typeface="Arial" charset="0"/>
-                        <a:ea typeface="Arial" charset="0"/>
-                        <a:cs typeface="Arial" charset="0"/>
+                        <a:latin typeface="Inter" charset="0"/>
+                        <a:ea typeface="Inter" charset="0"/>
+                        <a:cs typeface="Inter" charset="0"/>
                       </a:endParaRPr>
                     </a:p>
                   </a:txBody>
@@ -2699,16 +2699,16 @@
                           <a:solidFill>
                             <a:srgbClr val="D1D5DB"/>
                           </a:solidFill>
-                          <a:latin typeface="Arial" pitchFamily="34" charset="0"/>
-                          <a:ea typeface="Arial" pitchFamily="34" charset="-122"/>
-                          <a:cs typeface="Arial" pitchFamily="34" charset="-120"/>
+                          <a:latin typeface="Inter" pitchFamily="34" charset="0"/>
+                          <a:ea typeface="Inter" pitchFamily="34" charset="-122"/>
+                          <a:cs typeface="Inter" pitchFamily="34" charset="-120"/>
                         </a:rPr>
                         <a:t>75% MIS effort reduction</a:t>
                       </a:r>
                       <a:endParaRPr lang="en-US" sz="1000" dirty="0">
-                        <a:latin typeface="Arial" charset="0"/>
-                        <a:ea typeface="Arial" charset="0"/>
-                        <a:cs typeface="Arial" charset="0"/>
+                        <a:latin typeface="Inter" charset="0"/>
+                        <a:ea typeface="Inter" charset="0"/>
+                        <a:cs typeface="Inter" charset="0"/>
                       </a:endParaRPr>
                     </a:p>
                   </a:txBody>
@@ -2745,16 +2745,16 @@
                           <a:solidFill>
                             <a:srgbClr val="D1D5DB"/>
                           </a:solidFill>
-                          <a:latin typeface="Arial" pitchFamily="34" charset="0"/>
-                          <a:ea typeface="Arial" pitchFamily="34" charset="-122"/>
-                          <a:cs typeface="Arial" pitchFamily="34" charset="-120"/>
+                          <a:latin typeface="Inter" pitchFamily="34" charset="0"/>
+                          <a:ea typeface="Inter" pitchFamily="34" charset="-122"/>
+                          <a:cs typeface="Inter" pitchFamily="34" charset="-120"/>
                         </a:rPr>
                         <a:t>NCR Tracker</a:t>
                       </a:r>
                       <a:endParaRPr lang="en-US" sz="1000" dirty="0">
-                        <a:latin typeface="Arial" charset="0"/>
-                        <a:ea typeface="Arial" charset="0"/>
-                        <a:cs typeface="Arial" charset="0"/>
+                        <a:latin typeface="Inter" charset="0"/>
+                        <a:ea typeface="Inter" charset="0"/>
+                        <a:cs typeface="Inter" charset="0"/>
                       </a:endParaRPr>
                     </a:p>
                   </a:txBody>
@@ -2789,16 +2789,16 @@
                           <a:solidFill>
                             <a:srgbClr val="D1D5DB"/>
                           </a:solidFill>
-                          <a:latin typeface="Arial" pitchFamily="34" charset="0"/>
-                          <a:ea typeface="Arial" pitchFamily="34" charset="-122"/>
-                          <a:cs typeface="Arial" pitchFamily="34" charset="-120"/>
+                          <a:latin typeface="Inter" pitchFamily="34" charset="0"/>
+                          <a:ea typeface="Inter" pitchFamily="34" charset="-122"/>
+                          <a:cs typeface="Inter" pitchFamily="34" charset="-120"/>
                         </a:rPr>
                         <a:t>Quality Intelligence</a:t>
                       </a:r>
                       <a:endParaRPr lang="en-US" sz="1000" dirty="0">
-                        <a:latin typeface="Arial" charset="0"/>
-                        <a:ea typeface="Arial" charset="0"/>
-                        <a:cs typeface="Arial" charset="0"/>
+                        <a:latin typeface="Inter" charset="0"/>
+                        <a:ea typeface="Inter" charset="0"/>
+                        <a:cs typeface="Inter" charset="0"/>
                       </a:endParaRPr>
                     </a:p>
                   </a:txBody>
@@ -2833,16 +2833,16 @@
                           <a:solidFill>
                             <a:srgbClr val="D1D5DB"/>
                           </a:solidFill>
-                          <a:latin typeface="Arial" pitchFamily="34" charset="0"/>
-                          <a:ea typeface="Arial" pitchFamily="34" charset="-122"/>
-                          <a:cs typeface="Arial" pitchFamily="34" charset="-120"/>
+                          <a:latin typeface="Inter" pitchFamily="34" charset="0"/>
+                          <a:ea typeface="Inter" pitchFamily="34" charset="-122"/>
+                          <a:cs typeface="Inter" pitchFamily="34" charset="-120"/>
                         </a:rPr>
                         <a:t>Production</a:t>
                       </a:r>
                       <a:endParaRPr lang="en-US" sz="1000" dirty="0">
-                        <a:latin typeface="Arial" charset="0"/>
-                        <a:ea typeface="Arial" charset="0"/>
-                        <a:cs typeface="Arial" charset="0"/>
+                        <a:latin typeface="Inter" charset="0"/>
+                        <a:ea typeface="Inter" charset="0"/>
+                        <a:cs typeface="Inter" charset="0"/>
                       </a:endParaRPr>
                     </a:p>
                   </a:txBody>
@@ -2877,16 +2877,16 @@
                           <a:solidFill>
                             <a:srgbClr val="D1D5DB"/>
                           </a:solidFill>
-                          <a:latin typeface="Arial" pitchFamily="34" charset="0"/>
-                          <a:ea typeface="Arial" pitchFamily="34" charset="-122"/>
-                          <a:cs typeface="Arial" pitchFamily="34" charset="-120"/>
+                          <a:latin typeface="Inter" pitchFamily="34" charset="0"/>
+                          <a:ea typeface="Inter" pitchFamily="34" charset="-122"/>
+                          <a:cs typeface="Inter" pitchFamily="34" charset="-120"/>
                         </a:rPr>
                         <a:t>40%+ faster closure</a:t>
                       </a:r>
                       <a:endParaRPr lang="en-US" sz="1000" dirty="0">
-                        <a:latin typeface="Arial" charset="0"/>
-                        <a:ea typeface="Arial" charset="0"/>
-                        <a:cs typeface="Arial" charset="0"/>
+                        <a:latin typeface="Inter" charset="0"/>
+                        <a:ea typeface="Inter" charset="0"/>
+                        <a:cs typeface="Inter" charset="0"/>
                       </a:endParaRPr>
                     </a:p>
                   </a:txBody>
@@ -2923,16 +2923,16 @@
                           <a:solidFill>
                             <a:srgbClr val="D1D5DB"/>
                           </a:solidFill>
-                          <a:latin typeface="Arial" pitchFamily="34" charset="0"/>
-                          <a:ea typeface="Arial" pitchFamily="34" charset="-122"/>
-                          <a:cs typeface="Arial" pitchFamily="34" charset="-120"/>
+                          <a:latin typeface="Inter" pitchFamily="34" charset="0"/>
+                          <a:ea typeface="Inter" pitchFamily="34" charset="-122"/>
+                          <a:cs typeface="Inter" pitchFamily="34" charset="-120"/>
                         </a:rPr>
                         <a:t>Contract Forensics</a:t>
                       </a:r>
                       <a:endParaRPr lang="en-US" sz="1000" dirty="0">
-                        <a:latin typeface="Arial" charset="0"/>
-                        <a:ea typeface="Arial" charset="0"/>
-                        <a:cs typeface="Arial" charset="0"/>
+                        <a:latin typeface="Inter" charset="0"/>
+                        <a:ea typeface="Inter" charset="0"/>
+                        <a:cs typeface="Inter" charset="0"/>
                       </a:endParaRPr>
                     </a:p>
                   </a:txBody>
@@ -2967,16 +2967,16 @@
                           <a:solidFill>
                             <a:srgbClr val="D1D5DB"/>
                           </a:solidFill>
-                          <a:latin typeface="Arial" pitchFamily="34" charset="0"/>
-                          <a:ea typeface="Arial" pitchFamily="34" charset="-122"/>
-                          <a:cs typeface="Arial" pitchFamily="34" charset="-120"/>
+                          <a:latin typeface="Inter" pitchFamily="34" charset="0"/>
+                          <a:ea typeface="Inter" pitchFamily="34" charset="-122"/>
+                          <a:cs typeface="Inter" pitchFamily="34" charset="-120"/>
                         </a:rPr>
                         <a:t>Contract Intelligence</a:t>
                       </a:r>
                       <a:endParaRPr lang="en-US" sz="1000" dirty="0">
-                        <a:latin typeface="Arial" charset="0"/>
-                        <a:ea typeface="Arial" charset="0"/>
-                        <a:cs typeface="Arial" charset="0"/>
+                        <a:latin typeface="Inter" charset="0"/>
+                        <a:ea typeface="Inter" charset="0"/>
+                        <a:cs typeface="Inter" charset="0"/>
                       </a:endParaRPr>
                     </a:p>
                   </a:txBody>
@@ -3011,16 +3011,16 @@
                           <a:solidFill>
                             <a:srgbClr val="D1D5DB"/>
                           </a:solidFill>
-                          <a:latin typeface="Arial" pitchFamily="34" charset="0"/>
-                          <a:ea typeface="Arial" pitchFamily="34" charset="-122"/>
-                          <a:cs typeface="Arial" pitchFamily="34" charset="-120"/>
+                          <a:latin typeface="Inter" pitchFamily="34" charset="0"/>
+                          <a:ea typeface="Inter" pitchFamily="34" charset="-122"/>
+                          <a:cs typeface="Inter" pitchFamily="34" charset="-120"/>
                         </a:rPr>
                         <a:t>Demonstrable</a:t>
                       </a:r>
                       <a:endParaRPr lang="en-US" sz="1000" dirty="0">
-                        <a:latin typeface="Arial" charset="0"/>
-                        <a:ea typeface="Arial" charset="0"/>
-                        <a:cs typeface="Arial" charset="0"/>
+                        <a:latin typeface="Inter" charset="0"/>
+                        <a:ea typeface="Inter" charset="0"/>
+                        <a:cs typeface="Inter" charset="0"/>
                       </a:endParaRPr>
                     </a:p>
                   </a:txBody>
@@ -3055,16 +3055,16 @@
                           <a:solidFill>
                             <a:srgbClr val="D1D5DB"/>
                           </a:solidFill>
-                          <a:latin typeface="Arial" pitchFamily="34" charset="0"/>
-                          <a:ea typeface="Arial" pitchFamily="34" charset="-122"/>
-                          <a:cs typeface="Arial" pitchFamily="34" charset="-120"/>
+                          <a:latin typeface="Inter" pitchFamily="34" charset="0"/>
+                          <a:ea typeface="Inter" pitchFamily="34" charset="-122"/>
+                          <a:cs typeface="Inter" pitchFamily="34" charset="-120"/>
                         </a:rPr>
                         <a:t>Weeks → Hours review</a:t>
                       </a:r>
                       <a:endParaRPr lang="en-US" sz="1000" dirty="0">
-                        <a:latin typeface="Arial" charset="0"/>
-                        <a:ea typeface="Arial" charset="0"/>
-                        <a:cs typeface="Arial" charset="0"/>
+                        <a:latin typeface="Inter" charset="0"/>
+                        <a:ea typeface="Inter" charset="0"/>
+                        <a:cs typeface="Inter" charset="0"/>
                       </a:endParaRPr>
                     </a:p>
                   </a:txBody>
@@ -3101,16 +3101,16 @@
                           <a:solidFill>
                             <a:srgbClr val="D1D5DB"/>
                           </a:solidFill>
-                          <a:latin typeface="Arial" pitchFamily="34" charset="0"/>
-                          <a:ea typeface="Arial" pitchFamily="34" charset="-122"/>
-                          <a:cs typeface="Arial" pitchFamily="34" charset="-120"/>
+                          <a:latin typeface="Inter" pitchFamily="34" charset="0"/>
+                          <a:ea typeface="Inter" pitchFamily="34" charset="-122"/>
+                          <a:cs typeface="Inter" pitchFamily="34" charset="-120"/>
                         </a:rPr>
                         <a:t>OCR Intelligence</a:t>
                       </a:r>
                       <a:endParaRPr lang="en-US" sz="1000" dirty="0">
-                        <a:latin typeface="Arial" charset="0"/>
-                        <a:ea typeface="Arial" charset="0"/>
-                        <a:cs typeface="Arial" charset="0"/>
+                        <a:latin typeface="Inter" charset="0"/>
+                        <a:ea typeface="Inter" charset="0"/>
+                        <a:cs typeface="Inter" charset="0"/>
                       </a:endParaRPr>
                     </a:p>
                   </a:txBody>
@@ -3145,16 +3145,16 @@
                           <a:solidFill>
                             <a:srgbClr val="D1D5DB"/>
                           </a:solidFill>
-                          <a:latin typeface="Arial" pitchFamily="34" charset="0"/>
-                          <a:ea typeface="Arial" pitchFamily="34" charset="-122"/>
-                          <a:cs typeface="Arial" pitchFamily="34" charset="-120"/>
+                          <a:latin typeface="Inter" pitchFamily="34" charset="0"/>
+                          <a:ea typeface="Inter" pitchFamily="34" charset="-122"/>
+                          <a:cs typeface="Inter" pitchFamily="34" charset="-120"/>
                         </a:rPr>
                         <a:t>Document Intelligence</a:t>
                       </a:r>
                       <a:endParaRPr lang="en-US" sz="1000" dirty="0">
-                        <a:latin typeface="Arial" charset="0"/>
-                        <a:ea typeface="Arial" charset="0"/>
-                        <a:cs typeface="Arial" charset="0"/>
+                        <a:latin typeface="Inter" charset="0"/>
+                        <a:ea typeface="Inter" charset="0"/>
+                        <a:cs typeface="Inter" charset="0"/>
                       </a:endParaRPr>
                     </a:p>
                   </a:txBody>
@@ -3189,16 +3189,16 @@
                           <a:solidFill>
                             <a:srgbClr val="D1D5DB"/>
                           </a:solidFill>
-                          <a:latin typeface="Arial" pitchFamily="34" charset="0"/>
-                          <a:ea typeface="Arial" pitchFamily="34" charset="-122"/>
-                          <a:cs typeface="Arial" pitchFamily="34" charset="-120"/>
+                          <a:latin typeface="Inter" pitchFamily="34" charset="0"/>
+                          <a:ea typeface="Inter" pitchFamily="34" charset="-122"/>
+                          <a:cs typeface="Inter" pitchFamily="34" charset="-120"/>
                         </a:rPr>
                         <a:t>Demonstrable</a:t>
                       </a:r>
                       <a:endParaRPr lang="en-US" sz="1000" dirty="0">
-                        <a:latin typeface="Arial" charset="0"/>
-                        <a:ea typeface="Arial" charset="0"/>
-                        <a:cs typeface="Arial" charset="0"/>
+                        <a:latin typeface="Inter" charset="0"/>
+                        <a:ea typeface="Inter" charset="0"/>
+                        <a:cs typeface="Inter" charset="0"/>
                       </a:endParaRPr>
                     </a:p>
                   </a:txBody>
@@ -3233,16 +3233,16 @@
                           <a:solidFill>
                             <a:srgbClr val="D1D5DB"/>
                           </a:solidFill>
-                          <a:latin typeface="Arial" pitchFamily="34" charset="0"/>
-                          <a:ea typeface="Arial" pitchFamily="34" charset="-122"/>
-                          <a:cs typeface="Arial" pitchFamily="34" charset="-120"/>
+                          <a:latin typeface="Inter" pitchFamily="34" charset="0"/>
+                          <a:ea typeface="Inter" pitchFamily="34" charset="-122"/>
+                          <a:cs typeface="Inter" pitchFamily="34" charset="-120"/>
                         </a:rPr>
                         <a:t>98%+ accuracy</a:t>
                       </a:r>
                       <a:endParaRPr lang="en-US" sz="1000" dirty="0">
-                        <a:latin typeface="Arial" charset="0"/>
-                        <a:ea typeface="Arial" charset="0"/>
-                        <a:cs typeface="Arial" charset="0"/>
+                        <a:latin typeface="Inter" charset="0"/>
+                        <a:ea typeface="Inter" charset="0"/>
+                        <a:cs typeface="Inter" charset="0"/>
                       </a:endParaRPr>
                     </a:p>
                   </a:txBody>
@@ -3330,9 +3330,9 @@
                 <a:solidFill>
                   <a:srgbClr val="D1D5DB"/>
                 </a:solidFill>
-                <a:latin typeface="Arial" pitchFamily="34" charset="0"/>
-                <a:ea typeface="Arial" pitchFamily="34" charset="-122"/>
-                <a:cs typeface="Arial" pitchFamily="34" charset="-120"/>
+                <a:latin typeface="Inter" pitchFamily="34" charset="0"/>
+                <a:ea typeface="Inter" pitchFamily="34" charset="-122"/>
+                <a:cs typeface="Inter" pitchFamily="34" charset="-120"/>
               </a:rPr>
               <a:t>MAHSR T-3 Deployment</a:t>
             </a:r>
@@ -3369,9 +3369,9 @@
                 <a:solidFill>
                   <a:srgbClr val="2A6094"/>
                 </a:solidFill>
-                <a:latin typeface="Arial" pitchFamily="34" charset="0"/>
-                <a:ea typeface="Arial" pitchFamily="34" charset="-122"/>
-                <a:cs typeface="Arial" pitchFamily="34" charset="-120"/>
+                <a:latin typeface="Inter" pitchFamily="34" charset="0"/>
+                <a:ea typeface="Inter" pitchFamily="34" charset="-122"/>
+                <a:cs typeface="Inter" pitchFamily="34" charset="-120"/>
               </a:rPr>
               <a:t>Mumbai-Ahmedabad High-Speed Rail — T-3 Track Package</a:t>
             </a:r>
@@ -3419,16 +3419,16 @@
                           <a:solidFill>
                             <a:srgbClr val="FFFFFF"/>
                           </a:solidFill>
-                          <a:latin typeface="Arial" pitchFamily="34" charset="0"/>
-                          <a:ea typeface="Arial" pitchFamily="34" charset="-122"/>
-                          <a:cs typeface="Arial" pitchFamily="34" charset="-120"/>
+                          <a:latin typeface="Inter" pitchFamily="34" charset="0"/>
+                          <a:ea typeface="Inter" pitchFamily="34" charset="-122"/>
+                          <a:cs typeface="Inter" pitchFamily="34" charset="-120"/>
                         </a:rPr>
                         <a:t>Metric</a:t>
                       </a:r>
                       <a:endParaRPr lang="en-US" sz="1100" dirty="0">
-                        <a:latin typeface="Arial" charset="0"/>
-                        <a:ea typeface="Arial" charset="0"/>
-                        <a:cs typeface="Arial" charset="0"/>
+                        <a:latin typeface="Inter" charset="0"/>
+                        <a:ea typeface="Inter" charset="0"/>
+                        <a:cs typeface="Inter" charset="0"/>
                       </a:endParaRPr>
                     </a:p>
                   </a:txBody>
@@ -3463,16 +3463,16 @@
                           <a:solidFill>
                             <a:srgbClr val="FFFFFF"/>
                           </a:solidFill>
-                          <a:latin typeface="Arial" pitchFamily="34" charset="0"/>
-                          <a:ea typeface="Arial" pitchFamily="34" charset="-122"/>
-                          <a:cs typeface="Arial" pitchFamily="34" charset="-120"/>
+                          <a:latin typeface="Inter" pitchFamily="34" charset="0"/>
+                          <a:ea typeface="Inter" pitchFamily="34" charset="-122"/>
+                          <a:cs typeface="Inter" pitchFamily="34" charset="-120"/>
                         </a:rPr>
                         <a:t>Value</a:t>
                       </a:r>
                       <a:endParaRPr lang="en-US" sz="1100" dirty="0">
-                        <a:latin typeface="Arial" charset="0"/>
-                        <a:ea typeface="Arial" charset="0"/>
-                        <a:cs typeface="Arial" charset="0"/>
+                        <a:latin typeface="Inter" charset="0"/>
+                        <a:ea typeface="Inter" charset="0"/>
+                        <a:cs typeface="Inter" charset="0"/>
                       </a:endParaRPr>
                     </a:p>
                   </a:txBody>
@@ -3509,16 +3509,16 @@
                           <a:solidFill>
                             <a:srgbClr val="D1D5DB"/>
                           </a:solidFill>
-                          <a:latin typeface="Arial" pitchFamily="34" charset="0"/>
-                          <a:ea typeface="Arial" pitchFamily="34" charset="-122"/>
-                          <a:cs typeface="Arial" pitchFamily="34" charset="-120"/>
+                          <a:latin typeface="Inter" pitchFamily="34" charset="0"/>
+                          <a:ea typeface="Inter" pitchFamily="34" charset="-122"/>
+                          <a:cs typeface="Inter" pitchFamily="34" charset="-120"/>
                         </a:rPr>
                         <a:t>Contract Value</a:t>
                       </a:r>
                       <a:endParaRPr lang="en-US" sz="1000" dirty="0">
-                        <a:latin typeface="Arial" charset="0"/>
-                        <a:ea typeface="Arial" charset="0"/>
-                        <a:cs typeface="Arial" charset="0"/>
+                        <a:latin typeface="Inter" charset="0"/>
+                        <a:ea typeface="Inter" charset="0"/>
+                        <a:cs typeface="Inter" charset="0"/>
                       </a:endParaRPr>
                     </a:p>
                   </a:txBody>
@@ -3553,16 +3553,16 @@
                           <a:solidFill>
                             <a:srgbClr val="D1D5DB"/>
                           </a:solidFill>
-                          <a:latin typeface="Arial" pitchFamily="34" charset="0"/>
-                          <a:ea typeface="Arial" pitchFamily="34" charset="-122"/>
-                          <a:cs typeface="Arial" pitchFamily="34" charset="-120"/>
+                          <a:latin typeface="Inter" pitchFamily="34" charset="0"/>
+                          <a:ea typeface="Inter" pitchFamily="34" charset="-122"/>
+                          <a:cs typeface="Inter" pitchFamily="34" charset="-120"/>
                         </a:rPr>
                         <a:t>INR 3,142 Crore</a:t>
                       </a:r>
                       <a:endParaRPr lang="en-US" sz="1000" dirty="0">
-                        <a:latin typeface="Arial" charset="0"/>
-                        <a:ea typeface="Arial" charset="0"/>
-                        <a:cs typeface="Arial" charset="0"/>
+                        <a:latin typeface="Inter" charset="0"/>
+                        <a:ea typeface="Inter" charset="0"/>
+                        <a:cs typeface="Inter" charset="0"/>
                       </a:endParaRPr>
                     </a:p>
                   </a:txBody>
@@ -3599,16 +3599,16 @@
                           <a:solidFill>
                             <a:srgbClr val="D1D5DB"/>
                           </a:solidFill>
-                          <a:latin typeface="Arial" pitchFamily="34" charset="0"/>
-                          <a:ea typeface="Arial" pitchFamily="34" charset="-122"/>
-                          <a:cs typeface="Arial" pitchFamily="34" charset="-120"/>
+                          <a:latin typeface="Inter" pitchFamily="34" charset="0"/>
+                          <a:ea typeface="Inter" pitchFamily="34" charset="-122"/>
+                          <a:cs typeface="Inter" pitchFamily="34" charset="-120"/>
                         </a:rPr>
                         <a:t>Contract Form</a:t>
                       </a:r>
                       <a:endParaRPr lang="en-US" sz="1000" dirty="0">
-                        <a:latin typeface="Arial" charset="0"/>
-                        <a:ea typeface="Arial" charset="0"/>
-                        <a:cs typeface="Arial" charset="0"/>
+                        <a:latin typeface="Inter" charset="0"/>
+                        <a:ea typeface="Inter" charset="0"/>
+                        <a:cs typeface="Inter" charset="0"/>
                       </a:endParaRPr>
                     </a:p>
                   </a:txBody>
@@ -3643,16 +3643,16 @@
                           <a:solidFill>
                             <a:srgbClr val="D1D5DB"/>
                           </a:solidFill>
-                          <a:latin typeface="Arial" pitchFamily="34" charset="0"/>
-                          <a:ea typeface="Arial" pitchFamily="34" charset="-122"/>
-                          <a:cs typeface="Arial" pitchFamily="34" charset="-120"/>
+                          <a:latin typeface="Inter" pitchFamily="34" charset="0"/>
+                          <a:ea typeface="Inter" pitchFamily="34" charset="-122"/>
+                          <a:cs typeface="Inter" pitchFamily="34" charset="-120"/>
                         </a:rPr>
                         <a:t>FIDIC Yellow Book</a:t>
                       </a:r>
                       <a:endParaRPr lang="en-US" sz="1000" dirty="0">
-                        <a:latin typeface="Arial" charset="0"/>
-                        <a:ea typeface="Arial" charset="0"/>
-                        <a:cs typeface="Arial" charset="0"/>
+                        <a:latin typeface="Inter" charset="0"/>
+                        <a:ea typeface="Inter" charset="0"/>
+                        <a:cs typeface="Inter" charset="0"/>
                       </a:endParaRPr>
                     </a:p>
                   </a:txBody>
@@ -3689,16 +3689,16 @@
                           <a:solidFill>
                             <a:srgbClr val="D1D5DB"/>
                           </a:solidFill>
-                          <a:latin typeface="Arial" pitchFamily="34" charset="0"/>
-                          <a:ea typeface="Arial" pitchFamily="34" charset="-122"/>
-                          <a:cs typeface="Arial" pitchFamily="34" charset="-120"/>
+                          <a:latin typeface="Inter" pitchFamily="34" charset="0"/>
+                          <a:ea typeface="Inter" pitchFamily="34" charset="-122"/>
+                          <a:cs typeface="Inter" pitchFamily="34" charset="-120"/>
                         </a:rPr>
                         <a:t>Scope</a:t>
                       </a:r>
                       <a:endParaRPr lang="en-US" sz="1000" dirty="0">
-                        <a:latin typeface="Arial" charset="0"/>
-                        <a:ea typeface="Arial" charset="0"/>
-                        <a:cs typeface="Arial" charset="0"/>
+                        <a:latin typeface="Inter" charset="0"/>
+                        <a:ea typeface="Inter" charset="0"/>
+                        <a:cs typeface="Inter" charset="0"/>
                       </a:endParaRPr>
                     </a:p>
                   </a:txBody>
@@ -3733,16 +3733,16 @@
                           <a:solidFill>
                             <a:srgbClr val="D1D5DB"/>
                           </a:solidFill>
-                          <a:latin typeface="Arial" pitchFamily="34" charset="0"/>
-                          <a:ea typeface="Arial" pitchFamily="34" charset="-122"/>
-                          <a:cs typeface="Arial" pitchFamily="34" charset="-120"/>
+                          <a:latin typeface="Inter" pitchFamily="34" charset="0"/>
+                          <a:ea typeface="Inter" pitchFamily="34" charset="-122"/>
+                          <a:cs typeface="Inter" pitchFamily="34" charset="-120"/>
                         </a:rPr>
                         <a:t>115.877 km (Vadodara to Sabarmati)</a:t>
                       </a:r>
                       <a:endParaRPr lang="en-US" sz="1000" dirty="0">
-                        <a:latin typeface="Arial" charset="0"/>
-                        <a:ea typeface="Arial" charset="0"/>
-                        <a:cs typeface="Arial" charset="0"/>
+                        <a:latin typeface="Inter" charset="0"/>
+                        <a:ea typeface="Inter" charset="0"/>
+                        <a:cs typeface="Inter" charset="0"/>
                       </a:endParaRPr>
                     </a:p>
                   </a:txBody>
@@ -3779,16 +3779,16 @@
                           <a:solidFill>
                             <a:srgbClr val="D1D5DB"/>
                           </a:solidFill>
-                          <a:latin typeface="Arial" pitchFamily="34" charset="0"/>
-                          <a:ea typeface="Arial" pitchFamily="34" charset="-122"/>
-                          <a:cs typeface="Arial" pitchFamily="34" charset="-120"/>
+                          <a:latin typeface="Inter" pitchFamily="34" charset="0"/>
+                          <a:ea typeface="Inter" pitchFamily="34" charset="-122"/>
+                          <a:cs typeface="Inter" pitchFamily="34" charset="-120"/>
                         </a:rPr>
                         <a:t>Oversight</a:t>
                       </a:r>
                       <a:endParaRPr lang="en-US" sz="1000" dirty="0">
-                        <a:latin typeface="Arial" charset="0"/>
-                        <a:ea typeface="Arial" charset="0"/>
-                        <a:cs typeface="Arial" charset="0"/>
+                        <a:latin typeface="Inter" charset="0"/>
+                        <a:ea typeface="Inter" charset="0"/>
+                        <a:cs typeface="Inter" charset="0"/>
                       </a:endParaRPr>
                     </a:p>
                   </a:txBody>
@@ -3823,16 +3823,16 @@
                           <a:solidFill>
                             <a:srgbClr val="D1D5DB"/>
                           </a:solidFill>
-                          <a:latin typeface="Arial" pitchFamily="34" charset="0"/>
-                          <a:ea typeface="Arial" pitchFamily="34" charset="-122"/>
-                          <a:cs typeface="Arial" pitchFamily="34" charset="-120"/>
+                          <a:latin typeface="Inter" pitchFamily="34" charset="0"/>
+                          <a:ea typeface="Inter" pitchFamily="34" charset="-122"/>
+                          <a:cs typeface="Inter" pitchFamily="34" charset="-120"/>
                         </a:rPr>
                         <a:t>JICA / JICC</a:t>
                       </a:r>
                       <a:endParaRPr lang="en-US" sz="1000" dirty="0">
-                        <a:latin typeface="Arial" charset="0"/>
-                        <a:ea typeface="Arial" charset="0"/>
-                        <a:cs typeface="Arial" charset="0"/>
+                        <a:latin typeface="Inter" charset="0"/>
+                        <a:ea typeface="Inter" charset="0"/>
+                        <a:cs typeface="Inter" charset="0"/>
                       </a:endParaRPr>
                     </a:p>
                   </a:txBody>
@@ -3869,16 +3869,16 @@
                           <a:solidFill>
                             <a:srgbClr val="D1D5DB"/>
                           </a:solidFill>
-                          <a:latin typeface="Arial" pitchFamily="34" charset="0"/>
-                          <a:ea typeface="Arial" pitchFamily="34" charset="-122"/>
-                          <a:cs typeface="Arial" pitchFamily="34" charset="-120"/>
+                          <a:latin typeface="Inter" pitchFamily="34" charset="0"/>
+                          <a:ea typeface="Inter" pitchFamily="34" charset="-122"/>
+                          <a:cs typeface="Inter" pitchFamily="34" charset="-120"/>
                         </a:rPr>
                         <a:t>Employer</a:t>
                       </a:r>
                       <a:endParaRPr lang="en-US" sz="1000" dirty="0">
-                        <a:latin typeface="Arial" charset="0"/>
-                        <a:ea typeface="Arial" charset="0"/>
-                        <a:cs typeface="Arial" charset="0"/>
+                        <a:latin typeface="Inter" charset="0"/>
+                        <a:ea typeface="Inter" charset="0"/>
+                        <a:cs typeface="Inter" charset="0"/>
                       </a:endParaRPr>
                     </a:p>
                   </a:txBody>
@@ -3913,16 +3913,16 @@
                           <a:solidFill>
                             <a:srgbClr val="D1D5DB"/>
                           </a:solidFill>
-                          <a:latin typeface="Arial" pitchFamily="34" charset="0"/>
-                          <a:ea typeface="Arial" pitchFamily="34" charset="-122"/>
-                          <a:cs typeface="Arial" pitchFamily="34" charset="-120"/>
+                          <a:latin typeface="Inter" pitchFamily="34" charset="0"/>
+                          <a:ea typeface="Inter" pitchFamily="34" charset="-122"/>
+                          <a:cs typeface="Inter" pitchFamily="34" charset="-120"/>
                         </a:rPr>
                         <a:t>NHSRCL</a:t>
                       </a:r>
                       <a:endParaRPr lang="en-US" sz="1000" dirty="0">
-                        <a:latin typeface="Arial" charset="0"/>
-                        <a:ea typeface="Arial" charset="0"/>
-                        <a:cs typeface="Arial" charset="0"/>
+                        <a:latin typeface="Inter" charset="0"/>
+                        <a:ea typeface="Inter" charset="0"/>
+                        <a:cs typeface="Inter" charset="0"/>
                       </a:endParaRPr>
                     </a:p>
                   </a:txBody>
@@ -3959,16 +3959,16 @@
                           <a:solidFill>
                             <a:srgbClr val="D1D5DB"/>
                           </a:solidFill>
-                          <a:latin typeface="Arial" pitchFamily="34" charset="0"/>
-                          <a:ea typeface="Arial" pitchFamily="34" charset="-122"/>
-                          <a:cs typeface="Arial" pitchFamily="34" charset="-120"/>
+                          <a:latin typeface="Inter" pitchFamily="34" charset="0"/>
+                          <a:ea typeface="Inter" pitchFamily="34" charset="-122"/>
+                          <a:cs typeface="Inter" pitchFamily="34" charset="-120"/>
                         </a:rPr>
                         <a:t>Contractor</a:t>
                       </a:r>
                       <a:endParaRPr lang="en-US" sz="1000" dirty="0">
-                        <a:latin typeface="Arial" charset="0"/>
-                        <a:ea typeface="Arial" charset="0"/>
-                        <a:cs typeface="Arial" charset="0"/>
+                        <a:latin typeface="Inter" charset="0"/>
+                        <a:ea typeface="Inter" charset="0"/>
+                        <a:cs typeface="Inter" charset="0"/>
                       </a:endParaRPr>
                     </a:p>
                   </a:txBody>
@@ -4003,16 +4003,16 @@
                           <a:solidFill>
                             <a:srgbClr val="D1D5DB"/>
                           </a:solidFill>
-                          <a:latin typeface="Arial" pitchFamily="34" charset="0"/>
-                          <a:ea typeface="Arial" pitchFamily="34" charset="-122"/>
-                          <a:cs typeface="Arial" pitchFamily="34" charset="-120"/>
+                          <a:latin typeface="Inter" pitchFamily="34" charset="0"/>
+                          <a:ea typeface="Inter" pitchFamily="34" charset="-122"/>
+                          <a:cs typeface="Inter" pitchFamily="34" charset="-120"/>
                         </a:rPr>
                         <a:t>Larsen &amp; Toubro Limited</a:t>
                       </a:r>
                       <a:endParaRPr lang="en-US" sz="1000" dirty="0">
-                        <a:latin typeface="Arial" charset="0"/>
-                        <a:ea typeface="Arial" charset="0"/>
-                        <a:cs typeface="Arial" charset="0"/>
+                        <a:latin typeface="Inter" charset="0"/>
+                        <a:ea typeface="Inter" charset="0"/>
+                        <a:cs typeface="Inter" charset="0"/>
                       </a:endParaRPr>
                     </a:p>
                   </a:txBody>
@@ -4100,9 +4100,9 @@
                 <a:solidFill>
                   <a:srgbClr val="D1D5DB"/>
                 </a:solidFill>
-                <a:latin typeface="Arial" pitchFamily="34" charset="0"/>
-                <a:ea typeface="Arial" pitchFamily="34" charset="-122"/>
-                <a:cs typeface="Arial" pitchFamily="34" charset="-120"/>
+                <a:latin typeface="Inter" pitchFamily="34" charset="0"/>
+                <a:ea typeface="Inter" pitchFamily="34" charset="-122"/>
+                <a:cs typeface="Inter" pitchFamily="34" charset="-120"/>
               </a:rPr>
               <a:t>EPC Intelligence Consulting</a:t>
             </a:r>
@@ -4151,16 +4151,16 @@
                           <a:solidFill>
                             <a:srgbClr val="FFFFFF"/>
                           </a:solidFill>
-                          <a:latin typeface="Arial" pitchFamily="34" charset="0"/>
-                          <a:ea typeface="Arial" pitchFamily="34" charset="-122"/>
-                          <a:cs typeface="Arial" pitchFamily="34" charset="-120"/>
+                          <a:latin typeface="Inter" pitchFamily="34" charset="0"/>
+                          <a:ea typeface="Inter" pitchFamily="34" charset="-122"/>
+                          <a:cs typeface="Inter" pitchFamily="34" charset="-120"/>
                         </a:rPr>
                         <a:t>Service</a:t>
                       </a:r>
                       <a:endParaRPr lang="en-US" sz="1100" dirty="0">
-                        <a:latin typeface="Arial" charset="0"/>
-                        <a:ea typeface="Arial" charset="0"/>
-                        <a:cs typeface="Arial" charset="0"/>
+                        <a:latin typeface="Inter" charset="0"/>
+                        <a:ea typeface="Inter" charset="0"/>
+                        <a:cs typeface="Inter" charset="0"/>
                       </a:endParaRPr>
                     </a:p>
                   </a:txBody>
@@ -4195,16 +4195,16 @@
                           <a:solidFill>
                             <a:srgbClr val="FFFFFF"/>
                           </a:solidFill>
-                          <a:latin typeface="Arial" pitchFamily="34" charset="0"/>
-                          <a:ea typeface="Arial" pitchFamily="34" charset="-122"/>
-                          <a:cs typeface="Arial" pitchFamily="34" charset="-120"/>
+                          <a:latin typeface="Inter" pitchFamily="34" charset="0"/>
+                          <a:ea typeface="Inter" pitchFamily="34" charset="-122"/>
+                          <a:cs typeface="Inter" pitchFamily="34" charset="-120"/>
                         </a:rPr>
                         <a:t>Target Client</a:t>
                       </a:r>
                       <a:endParaRPr lang="en-US" sz="1100" dirty="0">
-                        <a:latin typeface="Arial" charset="0"/>
-                        <a:ea typeface="Arial" charset="0"/>
-                        <a:cs typeface="Arial" charset="0"/>
+                        <a:latin typeface="Inter" charset="0"/>
+                        <a:ea typeface="Inter" charset="0"/>
+                        <a:cs typeface="Inter" charset="0"/>
                       </a:endParaRPr>
                     </a:p>
                   </a:txBody>
@@ -4239,16 +4239,16 @@
                           <a:solidFill>
                             <a:srgbClr val="FFFFFF"/>
                           </a:solidFill>
-                          <a:latin typeface="Arial" pitchFamily="34" charset="0"/>
-                          <a:ea typeface="Arial" pitchFamily="34" charset="-122"/>
-                          <a:cs typeface="Arial" pitchFamily="34" charset="-120"/>
+                          <a:latin typeface="Inter" pitchFamily="34" charset="0"/>
+                          <a:ea typeface="Inter" pitchFamily="34" charset="-122"/>
+                          <a:cs typeface="Inter" pitchFamily="34" charset="-120"/>
                         </a:rPr>
                         <a:t>Duration</a:t>
                       </a:r>
                       <a:endParaRPr lang="en-US" sz="1100" dirty="0">
-                        <a:latin typeface="Arial" charset="0"/>
-                        <a:ea typeface="Arial" charset="0"/>
-                        <a:cs typeface="Arial" charset="0"/>
+                        <a:latin typeface="Inter" charset="0"/>
+                        <a:ea typeface="Inter" charset="0"/>
+                        <a:cs typeface="Inter" charset="0"/>
                       </a:endParaRPr>
                     </a:p>
                   </a:txBody>
@@ -4285,16 +4285,16 @@
                           <a:solidFill>
                             <a:srgbClr val="D1D5DB"/>
                           </a:solidFill>
-                          <a:latin typeface="Arial" pitchFamily="34" charset="0"/>
-                          <a:ea typeface="Arial" pitchFamily="34" charset="-122"/>
-                          <a:cs typeface="Arial" pitchFamily="34" charset="-120"/>
+                          <a:latin typeface="Inter" pitchFamily="34" charset="0"/>
+                          <a:ea typeface="Inter" pitchFamily="34" charset="-122"/>
+                          <a:cs typeface="Inter" pitchFamily="34" charset="-120"/>
                         </a:rPr>
                         <a:t>AI Strategy Consulting</a:t>
                       </a:r>
                       <a:endParaRPr lang="en-US" sz="1000" dirty="0">
-                        <a:latin typeface="Arial" charset="0"/>
-                        <a:ea typeface="Arial" charset="0"/>
-                        <a:cs typeface="Arial" charset="0"/>
+                        <a:latin typeface="Inter" charset="0"/>
+                        <a:ea typeface="Inter" charset="0"/>
+                        <a:cs typeface="Inter" charset="0"/>
                       </a:endParaRPr>
                     </a:p>
                   </a:txBody>
@@ -4329,16 +4329,16 @@
                           <a:solidFill>
                             <a:srgbClr val="D1D5DB"/>
                           </a:solidFill>
-                          <a:latin typeface="Arial" pitchFamily="34" charset="0"/>
-                          <a:ea typeface="Arial" pitchFamily="34" charset="-122"/>
-                          <a:cs typeface="Arial" pitchFamily="34" charset="-120"/>
+                          <a:latin typeface="Inter" pitchFamily="34" charset="0"/>
+                          <a:ea typeface="Inter" pitchFamily="34" charset="-122"/>
+                          <a:cs typeface="Inter" pitchFamily="34" charset="-120"/>
                         </a:rPr>
                         <a:t>EPC contractors seeking AI adoption</a:t>
                       </a:r>
                       <a:endParaRPr lang="en-US" sz="1000" dirty="0">
-                        <a:latin typeface="Arial" charset="0"/>
-                        <a:ea typeface="Arial" charset="0"/>
-                        <a:cs typeface="Arial" charset="0"/>
+                        <a:latin typeface="Inter" charset="0"/>
+                        <a:ea typeface="Inter" charset="0"/>
+                        <a:cs typeface="Inter" charset="0"/>
                       </a:endParaRPr>
                     </a:p>
                   </a:txBody>
@@ -4373,16 +4373,16 @@
                           <a:solidFill>
                             <a:srgbClr val="D1D5DB"/>
                           </a:solidFill>
-                          <a:latin typeface="Arial" pitchFamily="34" charset="0"/>
-                          <a:ea typeface="Arial" pitchFamily="34" charset="-122"/>
-                          <a:cs typeface="Arial" pitchFamily="34" charset="-120"/>
+                          <a:latin typeface="Inter" pitchFamily="34" charset="0"/>
+                          <a:ea typeface="Inter" pitchFamily="34" charset="-122"/>
+                          <a:cs typeface="Inter" pitchFamily="34" charset="-120"/>
                         </a:rPr>
                         <a:t>60-90 min</a:t>
                       </a:r>
                       <a:endParaRPr lang="en-US" sz="1000" dirty="0">
-                        <a:latin typeface="Arial" charset="0"/>
-                        <a:ea typeface="Arial" charset="0"/>
-                        <a:cs typeface="Arial" charset="0"/>
+                        <a:latin typeface="Inter" charset="0"/>
+                        <a:ea typeface="Inter" charset="0"/>
+                        <a:cs typeface="Inter" charset="0"/>
                       </a:endParaRPr>
                     </a:p>
                   </a:txBody>
@@ -4419,16 +4419,16 @@
                           <a:solidFill>
                             <a:srgbClr val="D1D5DB"/>
                           </a:solidFill>
-                          <a:latin typeface="Arial" pitchFamily="34" charset="0"/>
-                          <a:ea typeface="Arial" pitchFamily="34" charset="-122"/>
-                          <a:cs typeface="Arial" pitchFamily="34" charset="-120"/>
+                          <a:latin typeface="Inter" pitchFamily="34" charset="0"/>
+                          <a:ea typeface="Inter" pitchFamily="34" charset="-122"/>
+                          <a:cs typeface="Inter" pitchFamily="34" charset="-120"/>
                         </a:rPr>
                         <a:t>Digital Twin Architecture</a:t>
                       </a:r>
                       <a:endParaRPr lang="en-US" sz="1000" dirty="0">
-                        <a:latin typeface="Arial" charset="0"/>
-                        <a:ea typeface="Arial" charset="0"/>
-                        <a:cs typeface="Arial" charset="0"/>
+                        <a:latin typeface="Inter" charset="0"/>
+                        <a:ea typeface="Inter" charset="0"/>
+                        <a:cs typeface="Inter" charset="0"/>
                       </a:endParaRPr>
                     </a:p>
                   </a:txBody>
@@ -4463,16 +4463,16 @@
                           <a:solidFill>
                             <a:srgbClr val="D1D5DB"/>
                           </a:solidFill>
-                          <a:latin typeface="Arial" pitchFamily="34" charset="0"/>
-                          <a:ea typeface="Arial" pitchFamily="34" charset="-122"/>
-                          <a:cs typeface="Arial" pitchFamily="34" charset="-120"/>
+                          <a:latin typeface="Inter" pitchFamily="34" charset="0"/>
+                          <a:ea typeface="Inter" pitchFamily="34" charset="-122"/>
+                          <a:cs typeface="Inter" pitchFamily="34" charset="-120"/>
                         </a:rPr>
                         <a:t>EPC contractors on linear infrastructure</a:t>
                       </a:r>
                       <a:endParaRPr lang="en-US" sz="1000" dirty="0">
-                        <a:latin typeface="Arial" charset="0"/>
-                        <a:ea typeface="Arial" charset="0"/>
-                        <a:cs typeface="Arial" charset="0"/>
+                        <a:latin typeface="Inter" charset="0"/>
+                        <a:ea typeface="Inter" charset="0"/>
+                        <a:cs typeface="Inter" charset="0"/>
                       </a:endParaRPr>
                     </a:p>
                   </a:txBody>
@@ -4507,16 +4507,16 @@
                           <a:solidFill>
                             <a:srgbClr val="D1D5DB"/>
                           </a:solidFill>
-                          <a:latin typeface="Arial" pitchFamily="34" charset="0"/>
-                          <a:ea typeface="Arial" pitchFamily="34" charset="-122"/>
-                          <a:cs typeface="Arial" pitchFamily="34" charset="-120"/>
+                          <a:latin typeface="Inter" pitchFamily="34" charset="0"/>
+                          <a:ea typeface="Inter" pitchFamily="34" charset="-122"/>
+                          <a:cs typeface="Inter" pitchFamily="34" charset="-120"/>
                         </a:rPr>
                         <a:t>90 min</a:t>
                       </a:r>
                       <a:endParaRPr lang="en-US" sz="1000" dirty="0">
-                        <a:latin typeface="Arial" charset="0"/>
-                        <a:ea typeface="Arial" charset="0"/>
-                        <a:cs typeface="Arial" charset="0"/>
+                        <a:latin typeface="Inter" charset="0"/>
+                        <a:ea typeface="Inter" charset="0"/>
+                        <a:cs typeface="Inter" charset="0"/>
                       </a:endParaRPr>
                     </a:p>
                   </a:txBody>
@@ -4553,16 +4553,16 @@
                           <a:solidFill>
                             <a:srgbClr val="D1D5DB"/>
                           </a:solidFill>
-                          <a:latin typeface="Arial" pitchFamily="34" charset="0"/>
-                          <a:ea typeface="Arial" pitchFamily="34" charset="-122"/>
-                          <a:cs typeface="Arial" pitchFamily="34" charset="-120"/>
+                          <a:latin typeface="Inter" pitchFamily="34" charset="0"/>
+                          <a:ea typeface="Inter" pitchFamily="34" charset="-122"/>
+                          <a:cs typeface="Inter" pitchFamily="34" charset="-120"/>
                         </a:rPr>
                         <a:t>Contract Intelligence Design</a:t>
                       </a:r>
                       <a:endParaRPr lang="en-US" sz="1000" dirty="0">
-                        <a:latin typeface="Arial" charset="0"/>
-                        <a:ea typeface="Arial" charset="0"/>
-                        <a:cs typeface="Arial" charset="0"/>
+                        <a:latin typeface="Inter" charset="0"/>
+                        <a:ea typeface="Inter" charset="0"/>
+                        <a:cs typeface="Inter" charset="0"/>
                       </a:endParaRPr>
                     </a:p>
                   </a:txBody>
@@ -4597,16 +4597,16 @@
                           <a:solidFill>
                             <a:srgbClr val="D1D5DB"/>
                           </a:solidFill>
-                          <a:latin typeface="Arial" pitchFamily="34" charset="0"/>
-                          <a:ea typeface="Arial" pitchFamily="34" charset="-122"/>
-                          <a:cs typeface="Arial" pitchFamily="34" charset="-120"/>
+                          <a:latin typeface="Inter" pitchFamily="34" charset="0"/>
+                          <a:ea typeface="Inter" pitchFamily="34" charset="-122"/>
+                          <a:cs typeface="Inter" pitchFamily="34" charset="-120"/>
                         </a:rPr>
                         <a:t>Legal counsel and contracts managers</a:t>
                       </a:r>
                       <a:endParaRPr lang="en-US" sz="1000" dirty="0">
-                        <a:latin typeface="Arial" charset="0"/>
-                        <a:ea typeface="Arial" charset="0"/>
-                        <a:cs typeface="Arial" charset="0"/>
+                        <a:latin typeface="Inter" charset="0"/>
+                        <a:ea typeface="Inter" charset="0"/>
+                        <a:cs typeface="Inter" charset="0"/>
                       </a:endParaRPr>
                     </a:p>
                   </a:txBody>
@@ -4641,16 +4641,16 @@
                           <a:solidFill>
                             <a:srgbClr val="D1D5DB"/>
                           </a:solidFill>
-                          <a:latin typeface="Arial" pitchFamily="34" charset="0"/>
-                          <a:ea typeface="Arial" pitchFamily="34" charset="-122"/>
-                          <a:cs typeface="Arial" pitchFamily="34" charset="-120"/>
+                          <a:latin typeface="Inter" pitchFamily="34" charset="0"/>
+                          <a:ea typeface="Inter" pitchFamily="34" charset="-122"/>
+                          <a:cs typeface="Inter" pitchFamily="34" charset="-120"/>
                         </a:rPr>
                         <a:t>60 min (NDA)</a:t>
                       </a:r>
                       <a:endParaRPr lang="en-US" sz="1000" dirty="0">
-                        <a:latin typeface="Arial" charset="0"/>
-                        <a:ea typeface="Arial" charset="0"/>
-                        <a:cs typeface="Arial" charset="0"/>
+                        <a:latin typeface="Inter" charset="0"/>
+                        <a:ea typeface="Inter" charset="0"/>
+                        <a:cs typeface="Inter" charset="0"/>
                       </a:endParaRPr>
                     </a:p>
                   </a:txBody>
@@ -4687,16 +4687,16 @@
                           <a:solidFill>
                             <a:srgbClr val="D1D5DB"/>
                           </a:solidFill>
-                          <a:latin typeface="Arial" pitchFamily="34" charset="0"/>
-                          <a:ea typeface="Arial" pitchFamily="34" charset="-122"/>
-                          <a:cs typeface="Arial" pitchFamily="34" charset="-120"/>
+                          <a:latin typeface="Inter" pitchFamily="34" charset="0"/>
+                          <a:ea typeface="Inter" pitchFamily="34" charset="-122"/>
+                          <a:cs typeface="Inter" pitchFamily="34" charset="-120"/>
                         </a:rPr>
                         <a:t>Expert Advisory</a:t>
                       </a:r>
                       <a:endParaRPr lang="en-US" sz="1000" dirty="0">
-                        <a:latin typeface="Arial" charset="0"/>
-                        <a:ea typeface="Arial" charset="0"/>
-                        <a:cs typeface="Arial" charset="0"/>
+                        <a:latin typeface="Inter" charset="0"/>
+                        <a:ea typeface="Inter" charset="0"/>
+                        <a:cs typeface="Inter" charset="0"/>
                       </a:endParaRPr>
                     </a:p>
                   </a:txBody>
@@ -4731,16 +4731,16 @@
                           <a:solidFill>
                             <a:srgbClr val="D1D5DB"/>
                           </a:solidFill>
-                          <a:latin typeface="Arial" pitchFamily="34" charset="0"/>
-                          <a:ea typeface="Arial" pitchFamily="34" charset="-122"/>
-                          <a:cs typeface="Arial" pitchFamily="34" charset="-120"/>
+                          <a:latin typeface="Inter" pitchFamily="34" charset="0"/>
+                          <a:ea typeface="Inter" pitchFamily="34" charset="-122"/>
+                          <a:cs typeface="Inter" pitchFamily="34" charset="-120"/>
                         </a:rPr>
                         <a:t>Legal counsel and expert witnesses</a:t>
                       </a:r>
                       <a:endParaRPr lang="en-US" sz="1000" dirty="0">
-                        <a:latin typeface="Arial" charset="0"/>
-                        <a:ea typeface="Arial" charset="0"/>
-                        <a:cs typeface="Arial" charset="0"/>
+                        <a:latin typeface="Inter" charset="0"/>
+                        <a:ea typeface="Inter" charset="0"/>
+                        <a:cs typeface="Inter" charset="0"/>
                       </a:endParaRPr>
                     </a:p>
                   </a:txBody>
@@ -4775,16 +4775,16 @@
                           <a:solidFill>
                             <a:srgbClr val="D1D5DB"/>
                           </a:solidFill>
-                          <a:latin typeface="Arial" pitchFamily="34" charset="0"/>
-                          <a:ea typeface="Arial" pitchFamily="34" charset="-122"/>
-                          <a:cs typeface="Arial" pitchFamily="34" charset="-120"/>
+                          <a:latin typeface="Inter" pitchFamily="34" charset="0"/>
+                          <a:ea typeface="Inter" pitchFamily="34" charset="-122"/>
+                          <a:cs typeface="Inter" pitchFamily="34" charset="-120"/>
                         </a:rPr>
                         <a:t>30-60 min (NDA)</a:t>
                       </a:r>
                       <a:endParaRPr lang="en-US" sz="1000" dirty="0">
-                        <a:latin typeface="Arial" charset="0"/>
-                        <a:ea typeface="Arial" charset="0"/>
-                        <a:cs typeface="Arial" charset="0"/>
+                        <a:latin typeface="Inter" charset="0"/>
+                        <a:ea typeface="Inter" charset="0"/>
+                        <a:cs typeface="Inter" charset="0"/>
                       </a:endParaRPr>
                     </a:p>
                   </a:txBody>
@@ -4821,16 +4821,16 @@
                           <a:solidFill>
                             <a:srgbClr val="D1D5DB"/>
                           </a:solidFill>
-                          <a:latin typeface="Arial" pitchFamily="34" charset="0"/>
-                          <a:ea typeface="Arial" pitchFamily="34" charset="-122"/>
-                          <a:cs typeface="Arial" pitchFamily="34" charset="-120"/>
+                          <a:latin typeface="Inter" pitchFamily="34" charset="0"/>
+                          <a:ea typeface="Inter" pitchFamily="34" charset="-122"/>
+                          <a:cs typeface="Inter" pitchFamily="34" charset="-120"/>
                         </a:rPr>
                         <a:t>Planning &amp; Scheduling Advisory</a:t>
                       </a:r>
                       <a:endParaRPr lang="en-US" sz="1000" dirty="0">
-                        <a:latin typeface="Arial" charset="0"/>
-                        <a:ea typeface="Arial" charset="0"/>
-                        <a:cs typeface="Arial" charset="0"/>
+                        <a:latin typeface="Inter" charset="0"/>
+                        <a:ea typeface="Inter" charset="0"/>
+                        <a:cs typeface="Inter" charset="0"/>
                       </a:endParaRPr>
                     </a:p>
                   </a:txBody>
@@ -4865,16 +4865,16 @@
                           <a:solidFill>
                             <a:srgbClr val="D1D5DB"/>
                           </a:solidFill>
-                          <a:latin typeface="Arial" pitchFamily="34" charset="0"/>
-                          <a:ea typeface="Arial" pitchFamily="34" charset="-122"/>
-                          <a:cs typeface="Arial" pitchFamily="34" charset="-120"/>
+                          <a:latin typeface="Inter" pitchFamily="34" charset="0"/>
+                          <a:ea typeface="Inter" pitchFamily="34" charset="-122"/>
+                          <a:cs typeface="Inter" pitchFamily="34" charset="-120"/>
                         </a:rPr>
                         <a:t>EPC contractors and project controls teams</a:t>
                       </a:r>
                       <a:endParaRPr lang="en-US" sz="1000" dirty="0">
-                        <a:latin typeface="Arial" charset="0"/>
-                        <a:ea typeface="Arial" charset="0"/>
-                        <a:cs typeface="Arial" charset="0"/>
+                        <a:latin typeface="Inter" charset="0"/>
+                        <a:ea typeface="Inter" charset="0"/>
+                        <a:cs typeface="Inter" charset="0"/>
                       </a:endParaRPr>
                     </a:p>
                   </a:txBody>
@@ -4909,16 +4909,16 @@
                           <a:solidFill>
                             <a:srgbClr val="D1D5DB"/>
                           </a:solidFill>
-                          <a:latin typeface="Arial" pitchFamily="34" charset="0"/>
-                          <a:ea typeface="Arial" pitchFamily="34" charset="-122"/>
-                          <a:cs typeface="Arial" pitchFamily="34" charset="-120"/>
+                          <a:latin typeface="Inter" pitchFamily="34" charset="0"/>
+                          <a:ea typeface="Inter" pitchFamily="34" charset="-122"/>
+                          <a:cs typeface="Inter" pitchFamily="34" charset="-120"/>
                         </a:rPr>
                         <a:t>60 min</a:t>
                       </a:r>
                       <a:endParaRPr lang="en-US" sz="1000" dirty="0">
-                        <a:latin typeface="Arial" charset="0"/>
-                        <a:ea typeface="Arial" charset="0"/>
-                        <a:cs typeface="Arial" charset="0"/>
+                        <a:latin typeface="Inter" charset="0"/>
+                        <a:ea typeface="Inter" charset="0"/>
+                        <a:cs typeface="Inter" charset="0"/>
                       </a:endParaRPr>
                     </a:p>
                   </a:txBody>
@@ -4955,16 +4955,16 @@
                           <a:solidFill>
                             <a:srgbClr val="D1D5DB"/>
                           </a:solidFill>
-                          <a:latin typeface="Arial" pitchFamily="34" charset="0"/>
-                          <a:ea typeface="Arial" pitchFamily="34" charset="-122"/>
-                          <a:cs typeface="Arial" pitchFamily="34" charset="-120"/>
+                          <a:latin typeface="Inter" pitchFamily="34" charset="0"/>
+                          <a:ea typeface="Inter" pitchFamily="34" charset="-122"/>
+                          <a:cs typeface="Inter" pitchFamily="34" charset="-120"/>
                         </a:rPr>
                         <a:t>Delay Analysis &amp; EOT Support</a:t>
                       </a:r>
                       <a:endParaRPr lang="en-US" sz="1000" dirty="0">
-                        <a:latin typeface="Arial" charset="0"/>
-                        <a:ea typeface="Arial" charset="0"/>
-                        <a:cs typeface="Arial" charset="0"/>
+                        <a:latin typeface="Inter" charset="0"/>
+                        <a:ea typeface="Inter" charset="0"/>
+                        <a:cs typeface="Inter" charset="0"/>
                       </a:endParaRPr>
                     </a:p>
                   </a:txBody>
@@ -4999,16 +4999,16 @@
                           <a:solidFill>
                             <a:srgbClr val="D1D5DB"/>
                           </a:solidFill>
-                          <a:latin typeface="Arial" pitchFamily="34" charset="0"/>
-                          <a:ea typeface="Arial" pitchFamily="34" charset="-122"/>
-                          <a:cs typeface="Arial" pitchFamily="34" charset="-120"/>
+                          <a:latin typeface="Inter" pitchFamily="34" charset="0"/>
+                          <a:ea typeface="Inter" pitchFamily="34" charset="-122"/>
+                          <a:cs typeface="Inter" pitchFamily="34" charset="-120"/>
                         </a:rPr>
                         <a:t>Contract managers, legal counsel, project directors</a:t>
                       </a:r>
                       <a:endParaRPr lang="en-US" sz="1000" dirty="0">
-                        <a:latin typeface="Arial" charset="0"/>
-                        <a:ea typeface="Arial" charset="0"/>
-                        <a:cs typeface="Arial" charset="0"/>
+                        <a:latin typeface="Inter" charset="0"/>
+                        <a:ea typeface="Inter" charset="0"/>
+                        <a:cs typeface="Inter" charset="0"/>
                       </a:endParaRPr>
                     </a:p>
                   </a:txBody>
@@ -5043,16 +5043,16 @@
                           <a:solidFill>
                             <a:srgbClr val="D1D5DB"/>
                           </a:solidFill>
-                          <a:latin typeface="Arial" pitchFamily="34" charset="0"/>
-                          <a:ea typeface="Arial" pitchFamily="34" charset="-122"/>
-                          <a:cs typeface="Arial" pitchFamily="34" charset="-120"/>
+                          <a:latin typeface="Inter" pitchFamily="34" charset="0"/>
+                          <a:ea typeface="Inter" pitchFamily="34" charset="-122"/>
+                          <a:cs typeface="Inter" pitchFamily="34" charset="-120"/>
                         </a:rPr>
                         <a:t>60 min (NDA)</a:t>
                       </a:r>
                       <a:endParaRPr lang="en-US" sz="1000" dirty="0">
-                        <a:latin typeface="Arial" charset="0"/>
-                        <a:ea typeface="Arial" charset="0"/>
-                        <a:cs typeface="Arial" charset="0"/>
+                        <a:latin typeface="Inter" charset="0"/>
+                        <a:ea typeface="Inter" charset="0"/>
+                        <a:cs typeface="Inter" charset="0"/>
                       </a:endParaRPr>
                     </a:p>
                   </a:txBody>
@@ -5140,9 +5140,9 @@
                 <a:solidFill>
                   <a:srgbClr val="D1D5DB"/>
                 </a:solidFill>
-                <a:latin typeface="Arial" pitchFamily="34" charset="0"/>
-                <a:ea typeface="Arial" pitchFamily="34" charset="-122"/>
-                <a:cs typeface="Arial" pitchFamily="34" charset="-120"/>
+                <a:latin typeface="Inter" pitchFamily="34" charset="0"/>
+                <a:ea typeface="Inter" pitchFamily="34" charset="-122"/>
+                <a:cs typeface="Inter" pitchFamily="34" charset="-120"/>
               </a:rPr>
               <a:t>Contact Details</a:t>
             </a:r>
@@ -5179,9 +5179,9 @@
                 <a:solidFill>
                   <a:srgbClr val="D1D5DB"/>
                 </a:solidFill>
-                <a:latin typeface="Arial" pitchFamily="34" charset="0"/>
-                <a:ea typeface="Arial" pitchFamily="34" charset="-122"/>
-                <a:cs typeface="Arial" pitchFamily="34" charset="-120"/>
+                <a:latin typeface="Inter" pitchFamily="34" charset="0"/>
+                <a:ea typeface="Inter" pitchFamily="34" charset="-122"/>
+                <a:cs typeface="Inter" pitchFamily="34" charset="-120"/>
               </a:rPr>
               <a:t>Samanta Nayak
 </a:t>
@@ -5194,9 +5194,9 @@
                 <a:solidFill>
                   <a:srgbClr val="9CA3AF"/>
                 </a:solidFill>
-                <a:latin typeface="Arial" pitchFamily="34" charset="0"/>
-                <a:ea typeface="Arial" pitchFamily="34" charset="-122"/>
-                <a:cs typeface="Arial" pitchFamily="34" charset="-120"/>
+                <a:latin typeface="Inter" pitchFamily="34" charset="0"/>
+                <a:ea typeface="Inter" pitchFamily="34" charset="-122"/>
+                <a:cs typeface="Inter" pitchFamily="34" charset="-120"/>
               </a:rPr>
               <a:t>Manager — Contracts &amp; Claims | Infrastructure AI Architect
 </a:t>
@@ -5209,9 +5209,9 @@
                 <a:solidFill>
                   <a:srgbClr val="D1D5DB"/>
                 </a:solidFill>
-                <a:latin typeface="Arial" pitchFamily="34" charset="0"/>
-                <a:ea typeface="Arial" pitchFamily="34" charset="-122"/>
-                <a:cs typeface="Arial" pitchFamily="34" charset="-120"/>
+                <a:latin typeface="Inter" pitchFamily="34" charset="0"/>
+                <a:ea typeface="Inter" pitchFamily="34" charset="-122"/>
+                <a:cs typeface="Inter" pitchFamily="34" charset="-120"/>
               </a:rPr>
               <a:t>Website: https://inframindepc.com
 </a:t>
@@ -5224,9 +5224,9 @@
                 <a:solidFill>
                   <a:srgbClr val="D1D5DB"/>
                 </a:solidFill>
-                <a:latin typeface="Arial" pitchFamily="34" charset="0"/>
-                <a:ea typeface="Arial" pitchFamily="34" charset="-122"/>
-                <a:cs typeface="Arial" pitchFamily="34" charset="-120"/>
+                <a:latin typeface="Inter" pitchFamily="34" charset="0"/>
+                <a:ea typeface="Inter" pitchFamily="34" charset="-122"/>
+                <a:cs typeface="Inter" pitchFamily="34" charset="-120"/>
               </a:rPr>
               <a:t>Contact: https://inframindepc.com/contact
 </a:t>

</xml_diff>